<commit_message>
fix(sponsorship-desk): add Ms. C. Shruti Reddy, add Abhiramivutla@gmail.com, and update role to Co-Organiser
</commit_message>
<xml_diff>
--- a/public/pitchdeck.pptx
+++ b/public/pitchdeck.pptx
@@ -8159,8 +8159,8 @@
         </p:nvSpPr>
         <p:spPr>
           <a:xfrm>
-            <a:off x="731520" y="1097280"/>
-            <a:ext cx="3657600" cy="228600"/>
+            <a:off x="548640" y="1097280"/>
+            <a:ext cx="2468880" cy="228600"/>
           </a:xfrm>
           <a:prstGeom prst="rect">
             <a:avLst/>
@@ -8176,7 +8176,7 @@
               <a:buNone/>
             </a:pPr>
             <a:r>
-              <a:rPr lang="en-US" sz="1000" b="1" dirty="0">
+              <a:rPr lang="en-US" sz="950" b="1" dirty="0">
                 <a:solidFill>
                   <a:srgbClr val="EB0028"/>
                 </a:solidFill>
@@ -8184,9 +8184,9 @@
                 <a:ea typeface="Helvetica" pitchFamily="34" charset="-122"/>
                 <a:cs typeface="Helvetica" pitchFamily="34" charset="-120"/>
               </a:rPr>
-              <a:t>GET IN TOUCH</a:t>
-            </a:r>
-            <a:endParaRPr lang="en-US" sz="1000" dirty="0"/>
+              <a:t>CO-ORGANISER</a:t>
+            </a:r>
+            <a:endParaRPr lang="en-US" sz="950" dirty="0"/>
           </a:p>
         </p:txBody>
       </p:sp>
@@ -8198,8 +8198,8 @@
         </p:nvSpPr>
         <p:spPr>
           <a:xfrm>
-            <a:off x="731520" y="1371600"/>
-            <a:ext cx="3657600" cy="457200"/>
+            <a:off x="548640" y="1371600"/>
+            <a:ext cx="2468880" cy="411480"/>
           </a:xfrm>
           <a:prstGeom prst="rect">
             <a:avLst/>
@@ -8215,7 +8215,7 @@
               <a:buNone/>
             </a:pPr>
             <a:r>
-              <a:rPr lang="en-US" sz="2000" b="1" dirty="0">
+              <a:rPr lang="en-US" sz="1700" b="1" dirty="0">
                 <a:solidFill>
                   <a:srgbClr val="000000"/>
                 </a:solidFill>
@@ -8225,7 +8225,7 @@
               </a:rPr>
               <a:t>Yelamanchili Ananya</a:t>
             </a:r>
-            <a:endParaRPr lang="en-US" sz="2000" dirty="0"/>
+            <a:endParaRPr lang="en-US" sz="1700" dirty="0"/>
           </a:p>
         </p:txBody>
       </p:sp>
@@ -8237,8 +8237,8 @@
         </p:nvSpPr>
         <p:spPr>
           <a:xfrm>
-            <a:off x="731520" y="1828800"/>
-            <a:ext cx="3657600" cy="320040"/>
+            <a:off x="548640" y="1783080"/>
+            <a:ext cx="2468880" cy="320040"/>
           </a:xfrm>
           <a:prstGeom prst="rect">
             <a:avLst/>
@@ -8254,7 +8254,7 @@
               <a:buNone/>
             </a:pPr>
             <a:r>
-              <a:rPr lang="en-US" sz="1200" b="1" dirty="0">
+              <a:rPr lang="en-US" sz="1100" b="1" dirty="0">
                 <a:solidFill>
                   <a:srgbClr val="555555"/>
                 </a:solidFill>
@@ -8264,7 +8264,7 @@
               </a:rPr>
               <a:t>Co-Organiser, TEDxPORPS Youth 2026</a:t>
             </a:r>
-            <a:endParaRPr lang="en-US" sz="1200" dirty="0"/>
+            <a:endParaRPr lang="en-US" sz="1100" dirty="0"/>
           </a:p>
         </p:txBody>
       </p:sp>
@@ -8276,8 +8276,8 @@
         </p:nvSpPr>
         <p:spPr>
           <a:xfrm>
-            <a:off x="731520" y="2240280"/>
-            <a:ext cx="3657600" cy="731520"/>
+            <a:off x="548640" y="2194560"/>
+            <a:ext cx="2468880" cy="731520"/>
           </a:xfrm>
           <a:prstGeom prst="rect">
             <a:avLst/>
@@ -8291,12 +8291,12 @@
           <a:p>
             <a:pPr indent="0" marL="0">
               <a:lnSpc>
-                <a:spcPts val="1800"/>
+                <a:spcPts val="1600"/>
               </a:lnSpc>
               <a:buNone/>
             </a:pPr>
             <a:r>
-              <a:rPr lang="en-US" sz="1200" dirty="0">
+              <a:rPr lang="en-US" sz="1100" dirty="0">
                 <a:solidFill>
                   <a:srgbClr val="000000"/>
                 </a:solidFill>
@@ -8306,17 +8306,17 @@
               </a:rPr>
               <a:t>Email: yananyaanu@gmail.com</a:t>
             </a:r>
-            <a:endParaRPr lang="en-US" sz="1200" dirty="0"/>
+            <a:endParaRPr lang="en-US" sz="1100" dirty="0"/>
           </a:p>
           <a:p>
             <a:pPr indent="0" marL="0">
               <a:lnSpc>
-                <a:spcPts val="1800"/>
+                <a:spcPts val="1600"/>
               </a:lnSpc>
               <a:buNone/>
             </a:pPr>
             <a:r>
-              <a:rPr lang="en-US" sz="1200" dirty="0">
+              <a:rPr lang="en-US" sz="1100" dirty="0">
                 <a:solidFill>
                   <a:srgbClr val="000000"/>
                 </a:solidFill>
@@ -8326,7 +8326,7 @@
               </a:rPr>
               <a:t>Phone: 8977540506</a:t>
             </a:r>
-            <a:endParaRPr lang="en-US" sz="1200" dirty="0"/>
+            <a:endParaRPr lang="en-US" sz="1100" dirty="0"/>
           </a:p>
         </p:txBody>
       </p:sp>
@@ -8338,7 +8338,7 @@
         </p:nvSpPr>
         <p:spPr>
           <a:xfrm>
-            <a:off x="4572000" y="1280160"/>
+            <a:off x="3200400" y="1280160"/>
             <a:ext cx="0" cy="2926080"/>
           </a:xfrm>
           <a:prstGeom prst="line">
@@ -8361,8 +8361,8 @@
         </p:nvSpPr>
         <p:spPr>
           <a:xfrm>
-            <a:off x="4846320" y="1097280"/>
-            <a:ext cx="3566160" cy="228600"/>
+            <a:off x="3474720" y="1097280"/>
+            <a:ext cx="2468880" cy="228600"/>
           </a:xfrm>
           <a:prstGeom prst="rect">
             <a:avLst/>
@@ -8378,7 +8378,7 @@
               <a:buNone/>
             </a:pPr>
             <a:r>
-              <a:rPr lang="en-US" sz="1000" b="1" dirty="0">
+              <a:rPr lang="en-US" sz="950" b="1" dirty="0">
                 <a:solidFill>
                   <a:srgbClr val="EB0028"/>
                 </a:solidFill>
@@ -8386,9 +8386,9 @@
                 <a:ea typeface="Helvetica" pitchFamily="34" charset="-122"/>
                 <a:cs typeface="Helvetica" pitchFamily="34" charset="-120"/>
               </a:rPr>
-              <a:t>CO-CURATOR</a:t>
-            </a:r>
-            <a:endParaRPr lang="en-US" sz="1000" dirty="0"/>
+              <a:t>CO-ORGANISER</a:t>
+            </a:r>
+            <a:endParaRPr lang="en-US" sz="950" dirty="0"/>
           </a:p>
         </p:txBody>
       </p:sp>
@@ -8400,8 +8400,8 @@
         </p:nvSpPr>
         <p:spPr>
           <a:xfrm>
-            <a:off x="4846320" y="1371600"/>
-            <a:ext cx="3566160" cy="457200"/>
+            <a:off x="3474720" y="1371600"/>
+            <a:ext cx="2468880" cy="411480"/>
           </a:xfrm>
           <a:prstGeom prst="rect">
             <a:avLst/>
@@ -8417,7 +8417,7 @@
               <a:buNone/>
             </a:pPr>
             <a:r>
-              <a:rPr lang="en-US" sz="2000" b="1" dirty="0">
+              <a:rPr lang="en-US" sz="1700" b="1" dirty="0">
                 <a:solidFill>
                   <a:srgbClr val="000000"/>
                 </a:solidFill>
@@ -8427,7 +8427,7 @@
               </a:rPr>
               <a:t>Abhirami Vutla</a:t>
             </a:r>
-            <a:endParaRPr lang="en-US" sz="2000" dirty="0"/>
+            <a:endParaRPr lang="en-US" sz="1700" dirty="0"/>
           </a:p>
         </p:txBody>
       </p:sp>
@@ -8439,8 +8439,8 @@
         </p:nvSpPr>
         <p:spPr>
           <a:xfrm>
-            <a:off x="4846320" y="1828800"/>
-            <a:ext cx="3566160" cy="320040"/>
+            <a:off x="3474720" y="1783080"/>
+            <a:ext cx="2468880" cy="320040"/>
           </a:xfrm>
           <a:prstGeom prst="rect">
             <a:avLst/>
@@ -8456,7 +8456,7 @@
               <a:buNone/>
             </a:pPr>
             <a:r>
-              <a:rPr lang="en-US" sz="1200" b="1" dirty="0">
+              <a:rPr lang="en-US" sz="1100" b="1" dirty="0">
                 <a:solidFill>
                   <a:srgbClr val="555555"/>
                 </a:solidFill>
@@ -8466,7 +8466,7 @@
               </a:rPr>
               <a:t>Co-Organiser, TEDxPORPS Youth 2026</a:t>
             </a:r>
-            <a:endParaRPr lang="en-US" sz="1200" dirty="0"/>
+            <a:endParaRPr lang="en-US" sz="1100" dirty="0"/>
           </a:p>
         </p:txBody>
       </p:sp>
@@ -8478,8 +8478,8 @@
         </p:nvSpPr>
         <p:spPr>
           <a:xfrm>
-            <a:off x="4846320" y="2240280"/>
-            <a:ext cx="3566160" cy="914400"/>
+            <a:off x="3474720" y="2194560"/>
+            <a:ext cx="2468880" cy="731520"/>
           </a:xfrm>
           <a:prstGeom prst="rect">
             <a:avLst/>
@@ -8493,12 +8493,12 @@
           <a:p>
             <a:pPr indent="0" marL="0">
               <a:lnSpc>
-                <a:spcPts val="1800"/>
+                <a:spcPts val="1600"/>
               </a:lnSpc>
               <a:buNone/>
             </a:pPr>
             <a:r>
-              <a:rPr lang="en-US" sz="1200" dirty="0">
+              <a:rPr lang="en-US" sz="1100" dirty="0">
                 <a:solidFill>
                   <a:srgbClr val="000000"/>
                 </a:solidFill>
@@ -8506,19 +8506,19 @@
                 <a:ea typeface="Helvetica" pitchFamily="34" charset="-122"/>
                 <a:cs typeface="Helvetica" pitchFamily="34" charset="-120"/>
               </a:rPr>
-              <a:t>P. Obul Reddy Public School</a:t>
-            </a:r>
-            <a:endParaRPr lang="en-US" sz="1200" dirty="0"/>
+              <a:t>Email: Abhiramivutla@gmail.com</a:t>
+            </a:r>
+            <a:endParaRPr lang="en-US" sz="1100" dirty="0"/>
           </a:p>
           <a:p>
             <a:pPr indent="0" marL="0">
               <a:lnSpc>
-                <a:spcPts val="1800"/>
+                <a:spcPts val="1600"/>
               </a:lnSpc>
               <a:buNone/>
             </a:pPr>
             <a:r>
-              <a:rPr lang="en-US" sz="1200" dirty="0">
+              <a:rPr lang="en-US" sz="1100" dirty="0">
                 <a:solidFill>
                   <a:srgbClr val="000000"/>
                 </a:solidFill>
@@ -8526,29 +8526,9 @@
                 <a:ea typeface="Helvetica" pitchFamily="34" charset="-122"/>
                 <a:cs typeface="Helvetica" pitchFamily="34" charset="-120"/>
               </a:rPr>
-              <a:t>Jubilee Hills, Hyderabad, Telangana</a:t>
-            </a:r>
-            <a:endParaRPr lang="en-US" sz="1200" dirty="0"/>
-          </a:p>
-          <a:p>
-            <a:pPr indent="0" marL="0">
-              <a:lnSpc>
-                <a:spcPts val="1800"/>
-              </a:lnSpc>
-              <a:buNone/>
-            </a:pPr>
-            <a:r>
-              <a:rPr lang="en-US" sz="1200" dirty="0">
-                <a:solidFill>
-                  <a:srgbClr val="000000"/>
-                </a:solidFill>
-                <a:latin typeface="Helvetica" pitchFamily="34" charset="0"/>
-                <a:ea typeface="Helvetica" pitchFamily="34" charset="-122"/>
-                <a:cs typeface="Helvetica" pitchFamily="34" charset="-120"/>
-              </a:rPr>
               <a:t>Phone: +91 99593 02051</a:t>
             </a:r>
-            <a:endParaRPr lang="en-US" sz="1200" dirty="0"/>
+            <a:endParaRPr lang="en-US" sz="1100" dirty="0"/>
           </a:p>
         </p:txBody>
       </p:sp>
@@ -8560,8 +8540,8 @@
         </p:nvSpPr>
         <p:spPr>
           <a:xfrm>
-            <a:off x="731520" y="4526280"/>
-            <a:ext cx="7680960" cy="0"/>
+            <a:off x="6126480" y="1280160"/>
+            <a:ext cx="0" cy="2926080"/>
           </a:xfrm>
           <a:prstGeom prst="line">
             <a:avLst/>
@@ -8583,6 +8563,208 @@
         </p:nvSpPr>
         <p:spPr>
           <a:xfrm>
+            <a:off x="6400800" y="1097280"/>
+            <a:ext cx="2468880" cy="228600"/>
+          </a:xfrm>
+          <a:prstGeom prst="rect">
+            <a:avLst/>
+          </a:prstGeom>
+          <a:noFill/>
+          <a:ln/>
+        </p:spPr>
+        <p:txBody>
+          <a:bodyPr wrap="square" rtlCol="0" anchor="ctr"/>
+          <a:lstStyle/>
+          <a:p>
+            <a:pPr indent="0" marL="0">
+              <a:buNone/>
+            </a:pPr>
+            <a:r>
+              <a:rPr lang="en-US" sz="950" b="1" dirty="0">
+                <a:solidFill>
+                  <a:srgbClr val="EB0028"/>
+                </a:solidFill>
+                <a:latin typeface="Helvetica" pitchFamily="34" charset="0"/>
+                <a:ea typeface="Helvetica" pitchFamily="34" charset="-122"/>
+                <a:cs typeface="Helvetica" pitchFamily="34" charset="-120"/>
+              </a:rPr>
+              <a:t>TEACHER ORGANISER</a:t>
+            </a:r>
+            <a:endParaRPr lang="en-US" sz="950" dirty="0"/>
+          </a:p>
+        </p:txBody>
+      </p:sp>
+      <p:sp>
+        <p:nvSpPr>
+          <p:cNvPr id="15" name="Text 13"/>
+          <p:cNvSpPr/>
+          <p:nvPr/>
+        </p:nvSpPr>
+        <p:spPr>
+          <a:xfrm>
+            <a:off x="6400800" y="1371600"/>
+            <a:ext cx="2468880" cy="411480"/>
+          </a:xfrm>
+          <a:prstGeom prst="rect">
+            <a:avLst/>
+          </a:prstGeom>
+          <a:noFill/>
+          <a:ln/>
+        </p:spPr>
+        <p:txBody>
+          <a:bodyPr wrap="square" rtlCol="0" anchor="ctr"/>
+          <a:lstStyle/>
+          <a:p>
+            <a:pPr indent="0" marL="0">
+              <a:buNone/>
+            </a:pPr>
+            <a:r>
+              <a:rPr lang="en-US" sz="1700" b="1" dirty="0">
+                <a:solidFill>
+                  <a:srgbClr val="000000"/>
+                </a:solidFill>
+                <a:latin typeface="Helvetica" pitchFamily="34" charset="0"/>
+                <a:ea typeface="Helvetica" pitchFamily="34" charset="-122"/>
+                <a:cs typeface="Helvetica" pitchFamily="34" charset="-120"/>
+              </a:rPr>
+              <a:t>Ms. C. Shruti Reddy</a:t>
+            </a:r>
+            <a:endParaRPr lang="en-US" sz="1700" dirty="0"/>
+          </a:p>
+        </p:txBody>
+      </p:sp>
+      <p:sp>
+        <p:nvSpPr>
+          <p:cNvPr id="16" name="Text 14"/>
+          <p:cNvSpPr/>
+          <p:nvPr/>
+        </p:nvSpPr>
+        <p:spPr>
+          <a:xfrm>
+            <a:off x="6400800" y="1783080"/>
+            <a:ext cx="2468880" cy="320040"/>
+          </a:xfrm>
+          <a:prstGeom prst="rect">
+            <a:avLst/>
+          </a:prstGeom>
+          <a:noFill/>
+          <a:ln/>
+        </p:spPr>
+        <p:txBody>
+          <a:bodyPr wrap="square" rtlCol="0" anchor="ctr"/>
+          <a:lstStyle/>
+          <a:p>
+            <a:pPr indent="0" marL="0">
+              <a:buNone/>
+            </a:pPr>
+            <a:r>
+              <a:rPr lang="en-US" sz="1100" b="1" dirty="0">
+                <a:solidFill>
+                  <a:srgbClr val="555555"/>
+                </a:solidFill>
+                <a:latin typeface="Helvetica" pitchFamily="34" charset="0"/>
+                <a:ea typeface="Helvetica" pitchFamily="34" charset="-122"/>
+                <a:cs typeface="Helvetica" pitchFamily="34" charset="-120"/>
+              </a:rPr>
+              <a:t>Teacher Organiser, TEDxPORPS Youth 2026</a:t>
+            </a:r>
+            <a:endParaRPr lang="en-US" sz="1100" dirty="0"/>
+          </a:p>
+        </p:txBody>
+      </p:sp>
+      <p:sp>
+        <p:nvSpPr>
+          <p:cNvPr id="17" name="Text 15"/>
+          <p:cNvSpPr/>
+          <p:nvPr/>
+        </p:nvSpPr>
+        <p:spPr>
+          <a:xfrm>
+            <a:off x="6400800" y="2194560"/>
+            <a:ext cx="2468880" cy="731520"/>
+          </a:xfrm>
+          <a:prstGeom prst="rect">
+            <a:avLst/>
+          </a:prstGeom>
+          <a:noFill/>
+          <a:ln/>
+        </p:spPr>
+        <p:txBody>
+          <a:bodyPr wrap="square" rtlCol="0" anchor="ctr"/>
+          <a:lstStyle/>
+          <a:p>
+            <a:pPr indent="0" marL="0">
+              <a:lnSpc>
+                <a:spcPts val="1600"/>
+              </a:lnSpc>
+              <a:buNone/>
+            </a:pPr>
+            <a:r>
+              <a:rPr lang="en-US" sz="1100" dirty="0">
+                <a:solidFill>
+                  <a:srgbClr val="000000"/>
+                </a:solidFill>
+                <a:latin typeface="Helvetica" pitchFamily="34" charset="0"/>
+                <a:ea typeface="Helvetica" pitchFamily="34" charset="-122"/>
+                <a:cs typeface="Helvetica" pitchFamily="34" charset="-120"/>
+              </a:rPr>
+              <a:t>P. Obul Reddy Public School</a:t>
+            </a:r>
+            <a:endParaRPr lang="en-US" sz="1100" dirty="0"/>
+          </a:p>
+          <a:p>
+            <a:pPr indent="0" marL="0">
+              <a:lnSpc>
+                <a:spcPts val="1600"/>
+              </a:lnSpc>
+              <a:buNone/>
+            </a:pPr>
+            <a:r>
+              <a:rPr lang="en-US" sz="1100" dirty="0">
+                <a:solidFill>
+                  <a:srgbClr val="000000"/>
+                </a:solidFill>
+                <a:latin typeface="Helvetica" pitchFamily="34" charset="0"/>
+                <a:ea typeface="Helvetica" pitchFamily="34" charset="-122"/>
+                <a:cs typeface="Helvetica" pitchFamily="34" charset="-120"/>
+              </a:rPr>
+              <a:t>Phone: +91 91 77071 678</a:t>
+            </a:r>
+            <a:endParaRPr lang="en-US" sz="1100" dirty="0"/>
+          </a:p>
+        </p:txBody>
+      </p:sp>
+      <p:sp>
+        <p:nvSpPr>
+          <p:cNvPr id="18" name="Shape 16"/>
+          <p:cNvSpPr/>
+          <p:nvPr/>
+        </p:nvSpPr>
+        <p:spPr>
+          <a:xfrm>
+            <a:off x="731520" y="4526280"/>
+            <a:ext cx="7680960" cy="0"/>
+          </a:xfrm>
+          <a:prstGeom prst="line">
+            <a:avLst/>
+          </a:prstGeom>
+          <a:noFill/>
+          <a:ln w="12700">
+            <a:solidFill>
+              <a:srgbClr val="E2E2E2"/>
+            </a:solidFill>
+            <a:prstDash val="solid"/>
+          </a:ln>
+        </p:spPr>
+      </p:sp>
+      <p:sp>
+        <p:nvSpPr>
+          <p:cNvPr id="19" name="Text 17"/>
+          <p:cNvSpPr/>
+          <p:nvPr/>
+        </p:nvSpPr>
+        <p:spPr>
+          <a:xfrm>
             <a:off x="731520" y="4617720"/>
             <a:ext cx="4754880" cy="365760"/>
           </a:xfrm>
@@ -8644,7 +8826,7 @@
       </p:sp>
       <p:sp>
         <p:nvSpPr>
-          <p:cNvPr id="15" name="Text 13"/>
+          <p:cNvPr id="20" name="Text 18"/>
           <p:cNvSpPr/>
           <p:nvPr/>
         </p:nvSpPr>

</xml_diff>